<commit_message>
The film is up: every deliverable is now done
https://youtu.be/CMpV2y9Zoxk, public, three minutes, 4K.

The judges page deliverable table has no pending rows left. The README links
it under the live app. Slide 1 of the deck now carries it next to the live link
and the repository, with the other lines shifted to make room, so a judge who
only ever opens the PDF can still reach the film in one click. And the paste
block in the submission guide has the real URL instead of a placeholder.

Co-Authored-By: Claude Opus 5 (1M context) <noreply@anthropic.com>
</commit_message>
<xml_diff>
--- a/public/docs/Virasat-Team-USV-Deck.pptx
+++ b/public/docs/Virasat-Team-USV-Deck.pptx
@@ -2196,7 +2196,7 @@
         </p:nvSpPr>
         <p:spPr>
           <a:xfrm>
-            <a:off x="548640" y="3931920"/>
+            <a:off x="548640" y="4096512"/>
             <a:ext cx="3657600" cy="274320"/>
           </a:xfrm>
           <a:prstGeom prst="rect">
@@ -2235,7 +2235,7 @@
         </p:nvSpPr>
         <p:spPr>
           <a:xfrm>
-            <a:off x="548640" y="4279392"/>
+            <a:off x="548640" y="4425696"/>
             <a:ext cx="5486400" cy="274320"/>
           </a:xfrm>
           <a:prstGeom prst="rect">
@@ -2276,7 +2276,7 @@
         </p:nvSpPr>
         <p:spPr>
           <a:xfrm>
-            <a:off x="548640" y="3291840"/>
+            <a:off x="548640" y="3127248"/>
             <a:ext cx="4572000" cy="292608"/>
           </a:xfrm>
           <a:prstGeom prst="rect">
@@ -2324,26 +2324,26 @@
         </p:nvSpPr>
         <p:spPr>
           <a:xfrm>
-            <a:off x="548640" y="3611880"/>
-            <a:ext cx="4572000" cy="274320"/>
-          </a:xfrm>
-          <a:prstGeom prst="rect">
-            <a:avLst/>
-          </a:prstGeom>
-          <a:noFill/>
-          <a:ln/>
-        </p:spPr>
-        <p:txBody>
-          <a:bodyPr wrap="square" lIns="0" tIns="0" rIns="0" bIns="0" rtlCol="0" anchor="t"/>
-          <a:lstStyle/>
-          <a:p>
-            <a:pPr indent="0" marL="0">
-              <a:buNone/>
-            </a:pPr>
-            <a:r>
-              <a:rPr lang="en-US" sz="1100" u="sng" dirty="0">
-                <a:solidFill>
-                  <a:srgbClr val="CFE3DF"/>
+            <a:off x="548640" y="3438144"/>
+            <a:ext cx="4937760" cy="274320"/>
+          </a:xfrm>
+          <a:prstGeom prst="rect">
+            <a:avLst/>
+          </a:prstGeom>
+          <a:noFill/>
+          <a:ln/>
+        </p:spPr>
+        <p:txBody>
+          <a:bodyPr wrap="square" lIns="0" tIns="0" rIns="0" bIns="0" rtlCol="0" anchor="t"/>
+          <a:lstStyle/>
+          <a:p>
+            <a:pPr indent="0" marL="0">
+              <a:buNone/>
+            </a:pPr>
+            <a:r>
+              <a:rPr lang="en-US" sz="1150" b="1" u="sng" dirty="0">
+                <a:solidFill>
+                  <a:srgbClr val="FFFFFF"/>
                 </a:solidFill>
                 <a:latin typeface="Calibri" pitchFamily="34" charset="0"/>
                 <a:ea typeface="Calibri" pitchFamily="34" charset="-122"/>
@@ -2356,6 +2356,54 @@
                   </a:extLst>
                 </a:hlinkClick>
               </a:rPr>
+              <a:t>Watch the 3 minute demo: youtu.be/CMpV2y9Zoxk</a:t>
+            </a:r>
+            <a:endParaRPr lang="en-US" sz="1150" dirty="0"/>
+          </a:p>
+        </p:txBody>
+      </p:sp>
+      <p:sp>
+        <p:nvSpPr>
+          <p:cNvPr id="10" name="Text 8">
+            <a:hlinkClick r:id="rId3" tooltip=""/>
+          </p:cNvPr>
+          <p:cNvSpPr txBox="1"/>
+          <p:nvPr/>
+        </p:nvSpPr>
+        <p:spPr>
+          <a:xfrm>
+            <a:off x="548640" y="3730752"/>
+            <a:ext cx="4572000" cy="274320"/>
+          </a:xfrm>
+          <a:prstGeom prst="rect">
+            <a:avLst/>
+          </a:prstGeom>
+          <a:noFill/>
+          <a:ln/>
+        </p:spPr>
+        <p:txBody>
+          <a:bodyPr wrap="square" lIns="0" tIns="0" rIns="0" bIns="0" rtlCol="0" anchor="t"/>
+          <a:lstStyle/>
+          <a:p>
+            <a:pPr indent="0" marL="0">
+              <a:buNone/>
+            </a:pPr>
+            <a:r>
+              <a:rPr lang="en-US" sz="1100" u="sng" dirty="0">
+                <a:solidFill>
+                  <a:srgbClr val="CFE3DF"/>
+                </a:solidFill>
+                <a:latin typeface="Calibri" pitchFamily="34" charset="0"/>
+                <a:ea typeface="Calibri" pitchFamily="34" charset="-122"/>
+                <a:cs typeface="Calibri" pitchFamily="34" charset="-120"/>
+                <a:hlinkClick r:id="rId3" invalidUrl="" action="" tgtFrame="" tooltip="" history="1" highlightClick="0" endSnd="0">
+                  <a:extLst>
+                    <a:ext uri="{A12FA001-AC4F-418D-AE19-62706E023703}">
+                      <ahyp:hlinkClr xmlns:ahyp="http://schemas.microsoft.com/office/drawing/2018/hyperlinkcolor" val="tx"/>
+                    </a:ext>
+                  </a:extLst>
+                </a:hlinkClick>
+              </a:rPr>
               <a:t>Code: github.com/usv240/virasat</a:t>
             </a:r>
             <a:endParaRPr lang="en-US" sz="1100" dirty="0"/>
@@ -2364,7 +2412,7 @@
       </p:sp>
       <p:sp>
         <p:nvSpPr>
-          <p:cNvPr id="10" name="Shape 8"/>
+          <p:cNvPr id="11" name="Shape 9"/>
           <p:cNvSpPr/>
           <p:nvPr/>
         </p:nvSpPr>
@@ -2398,14 +2446,14 @@
       </p:sp>
       <p:pic>
         <p:nvPicPr>
-          <p:cNvPr id="11" name="Image 0" descr="preencoded.png">    </p:cNvPr>
+          <p:cNvPr id="12" name="Image 0" descr="preencoded.png">    </p:cNvPr>
           <p:cNvPicPr>
             <a:picLocks noChangeAspect="1"/>
           </p:cNvPicPr>
           <p:nvPr/>
         </p:nvPicPr>
         <p:blipFill>
-          <a:blip r:embed="rId3"/>
+          <a:blip r:embed="rId4"/>
           <a:stretch>
             <a:fillRect/>
           </a:stretch>
@@ -2422,7 +2470,7 @@
       </p:pic>
       <p:sp>
         <p:nvSpPr>
-          <p:cNvPr id="12" name="Text 9"/>
+          <p:cNvPr id="13" name="Text 10"/>
           <p:cNvSpPr txBox="1"/>
           <p:nvPr/>
         </p:nvSpPr>

</xml_diff>